<commit_message>
✨(back) restyle and edit a generated slide deck from the conversation
Let generate_presentation take colours, fonts and text sizes, keep the
deck with its sources in the tool result metadata, and add
update_presentation to restyle, edit or revert it in a later turn.

Signed-off-by: natoromano <nathanaelpromano@gmail.com>
</commit_message>
<xml_diff>
--- a/src/backend/chat/file_generation/templates/generic.pptx
+++ b/src/backend/chat/file_generation/templates/generic.pptx
@@ -1059,7 +1059,7 @@
         <p:spPr bwMode="gray">
           <a:xfrm>
             <a:off x="360000" y="2499742"/>
-            <a:ext cx="8424000" cy="1923504"/>
+            <a:ext cx="8424000" cy="1300000"/>
           </a:xfrm>
         </p:spPr>
         <p:txBody>
@@ -1092,13 +1092,6 @@
               <a:t>Titre</a:t>
             </a:r>
           </a:p>
-          <a:p>
-            <a:pPr lvl="1"/>
-            <a:r>
-              <a:rPr lang="fr-FR" dirty="0"/>
-              <a:t>Sous-titre</a:t>
-            </a:r>
-          </a:p>
         </p:txBody>
       </p:sp>
       <p:cxnSp>
@@ -1255,6 +1248,45 @@
           </a:prstGeom>
         </p:spPr>
       </p:pic>
+      <p:sp>
+        <p:nvSpPr>
+          <p:cNvPr id="16" name="Sous-titre"/>
+          <p:cNvSpPr>
+            <a:spLocks noGrp="1"/>
+          </p:cNvSpPr>
+          <p:nvPr>
+            <p:ph type="body" sz="quarter" idx="17" hasCustomPrompt="1"/>
+          </p:nvPr>
+        </p:nvSpPr>
+        <p:spPr bwMode="gray">
+          <a:xfrm>
+            <a:off x="360000" y="3849742"/>
+            <a:ext cx="8424000" cy="573504"/>
+          </a:xfrm>
+        </p:spPr>
+        <p:txBody>
+          <a:bodyPr/>
+          <a:lstStyle>
+            <a:lvl1pPr marL="0" indent="0">
+              <a:spcBef>
+                <a:spcPts val="500"/>
+              </a:spcBef>
+              <a:spcAft>
+                <a:spcPts val="0"/>
+              </a:spcAft>
+              <a:buNone/>
+              <a:defRPr sz="1850"/>
+            </a:lvl1pPr>
+          </a:lstStyle>
+          <a:p>
+            <a:pPr lvl="0"/>
+            <a:r>
+              <a:rPr lang="fr-FR" dirty="0"/>
+              <a:t>Sous-titre</a:t>
+            </a:r>
+          </a:p>
+        </p:txBody>
+      </p:sp>
     </p:spTree>
     <p:extLst>
       <p:ext uri="{BB962C8B-B14F-4D97-AF65-F5344CB8AC3E}">
@@ -1641,63 +1673,6 @@
           <a:chExt cx="0" cy="0"/>
         </a:xfrm>
       </p:grpSpPr>
-      <p:sp>
-        <p:nvSpPr>
-          <p:cNvPr id="8" name="Espace réservé pour une image  7"/>
-          <p:cNvSpPr>
-            <a:spLocks noGrp="1"/>
-          </p:cNvSpPr>
-          <p:nvPr>
-            <p:ph type="pic" sz="quarter" idx="13" hasCustomPrompt="1"/>
-          </p:nvPr>
-        </p:nvSpPr>
-        <p:spPr bwMode="gray">
-          <a:xfrm>
-            <a:off x="0" y="843558"/>
-            <a:ext cx="9144000" cy="4300842"/>
-          </a:xfrm>
-          <a:solidFill>
-            <a:schemeClr val="bg1">
-              <a:lumMod val="85000"/>
-            </a:schemeClr>
-          </a:solidFill>
-        </p:spPr>
-        <p:txBody>
-          <a:bodyPr tIns="1080000" anchor="ctr" anchorCtr="0"/>
-          <a:lstStyle>
-            <a:lvl1pPr algn="ctr">
-              <a:defRPr cap="all" baseline="0"/>
-            </a:lvl1pPr>
-          </a:lstStyle>
-          <a:p>
-            <a:r>
-              <a:rPr lang="fr-FR" dirty="0"/>
-              <a:t>Sélectionner l’icône pour insérer une image, </a:t>
-            </a:r>
-            <a:br>
-              <a:rPr lang="fr-FR" dirty="0"/>
-            </a:br>
-            <a:r>
-              <a:rPr lang="fr-FR" dirty="0"/>
-              <a:t>puis disposer l’image en arrière plan </a:t>
-            </a:r>
-            <a:br>
-              <a:rPr lang="fr-FR" dirty="0"/>
-            </a:br>
-            <a:r>
-              <a:rPr lang="fr-FR" dirty="0"/>
-              <a:t>(Sélectionner l’image avec le bouton droit de la souris / </a:t>
-            </a:r>
-            <a:br>
-              <a:rPr lang="fr-FR" dirty="0"/>
-            </a:br>
-            <a:r>
-              <a:rPr lang="fr-FR" dirty="0"/>
-              <a:t>Mettre à l’arrière plan)</a:t>
-            </a:r>
-          </a:p>
-        </p:txBody>
-      </p:sp>
       <p:sp>
         <p:nvSpPr>
           <p:cNvPr id="2" name="Titre 1"/>
@@ -1916,6 +1891,45 @@
           </a:p>
         </p:txBody>
       </p:sp>
+      <p:sp>
+        <p:nvSpPr>
+          <p:cNvPr id="9" name="Sous-titre"/>
+          <p:cNvSpPr>
+            <a:spLocks noGrp="1"/>
+          </p:cNvSpPr>
+          <p:nvPr>
+            <p:ph type="body" sz="quarter" idx="14" hasCustomPrompt="1"/>
+          </p:nvPr>
+        </p:nvSpPr>
+        <p:spPr bwMode="gray">
+          <a:xfrm>
+            <a:off x="359999" y="3884400"/>
+            <a:ext cx="8424000" cy="600000"/>
+          </a:xfrm>
+        </p:spPr>
+        <p:txBody>
+          <a:bodyPr lIns="0"/>
+          <a:lstStyle>
+            <a:lvl1pPr marL="0" indent="0">
+              <a:spcBef>
+                <a:spcPts val="500"/>
+              </a:spcBef>
+              <a:spcAft>
+                <a:spcPts val="0"/>
+              </a:spcAft>
+              <a:buNone/>
+              <a:defRPr sz="1850"/>
+            </a:lvl1pPr>
+          </a:lstStyle>
+          <a:p>
+            <a:pPr lvl="0"/>
+            <a:r>
+              <a:rPr lang="fr-FR" dirty="0"/>
+              <a:t>Sous-titre</a:t>
+            </a:r>
+          </a:p>
+        </p:txBody>
+      </p:sp>
     </p:spTree>
     <p:extLst>
       <p:ext uri="{BB962C8B-B14F-4D97-AF65-F5344CB8AC3E}">
@@ -3372,7 +3386,7 @@
         </a:spcAft>
         <a:buFont typeface="Arial" pitchFamily="34" charset="0"/>
         <a:buNone/>
-        <a:defRPr sz="1050" b="0" kern="1200">
+        <a:defRPr sz="1400" b="0" kern="1200">
           <a:solidFill>
             <a:schemeClr val="tx1"/>
           </a:solidFill>
@@ -3393,7 +3407,7 @@
         </a:spcAft>
         <a:buFont typeface="Arial" pitchFamily="34" charset="0"/>
         <a:buChar char="•"/>
-        <a:defRPr sz="950" kern="1200">
+        <a:defRPr sz="1250" kern="1200">
           <a:solidFill>
             <a:schemeClr val="tx1"/>
           </a:solidFill>
@@ -3415,7 +3429,7 @@
         <a:buSzPct val="100000"/>
         <a:buFont typeface="Arial" pitchFamily="34" charset="0"/>
         <a:buChar char="•"/>
-        <a:defRPr sz="850" kern="1200">
+        <a:defRPr sz="1100" kern="1200">
           <a:solidFill>
             <a:schemeClr val="tx1"/>
           </a:solidFill>
@@ -3437,7 +3451,7 @@
         <a:buSzPct val="100000"/>
         <a:buFont typeface="Arial" pitchFamily="34" charset="0"/>
         <a:buChar char="•"/>
-        <a:defRPr sz="750" kern="1200">
+        <a:defRPr sz="1000" kern="1200">
           <a:solidFill>
             <a:schemeClr val="tx1"/>
           </a:solidFill>
@@ -3459,7 +3473,7 @@
         <a:buSzPct val="100000"/>
         <a:buFont typeface="Arial" pitchFamily="34" charset="0"/>
         <a:buChar char="•"/>
-        <a:defRPr sz="700" kern="1200">
+        <a:defRPr sz="900" kern="1200">
           <a:solidFill>
             <a:schemeClr val="tx1"/>
           </a:solidFill>

</xml_diff>